<commit_message>
fix: update low-tech templates to match pitch-first model
Replace "Evidence Grid" with "Pitch Substance" in slide titles and
content across all PPTX files. Update AI prompts in speaker notes
to use pitch-coaching framing instead of evidence-auditing. Fix
"help me help me" typo in demo-day-prep prompts. Rename
deck-building subtitle from "From Evidence Grid to Investor Deck"
to "From Narrative to Investor Deck".

Co-Authored-By: Claude Opus 4.6 (1M context) <noreply@anthropic.com>
</commit_message>
<xml_diff>
--- a/low-tech/pitch-narrative.pptx
+++ b/low-tech/pitch-narrative.pptx
@@ -509,34 +509,39 @@
           <a:lstStyle/>
           <a:p>
             <a:r>
-              <a:t>AI PROMPT (paste into ChatGPT or Claude):</a:t>
+              <a:t>AI PROMPT (paste into ChatGPT or Claude):
+I am building [describe your startup in 2-3 sentences]. Help me build my pitch narrative. For each of these 10 elements (Hook, Problem, Solution, Market, Product, Business Model, Traction, Team, Vision, The Ask), ask me about:
+1. Key Narrative - the core message for this element
+2. Proof Points - what backs it up and makes it credible
+3. So What? - why an investor should care
+Challenge weak claims and rate my pitch readiness as Strong, Moderate, Weak, or Assumption. Help me build a compelling story, not just a list of facts.</a:t>
             </a:r>
           </a:p>
           <a:p/>
           <a:p>
             <a:r>
-              <a:t>I am building [describe your startup in 2-3 sentences]. Help me fill in my evidence grid. For each of these 10 elements (Hook, Problem, Solution, Market, Product, Business Model, Traction, Team, Vision, The Ask), ask me about:</a:t>
-            </a:r>
-          </a:p>
-          <a:p>
-            <a:r>
-              <a:t>1. Key Narrative - the core message for this element</a:t>
-            </a:r>
-          </a:p>
-          <a:p>
-            <a:r>
-              <a:t>2. Proof Points - specific evidence that backs it up</a:t>
-            </a:r>
-          </a:p>
-          <a:p>
-            <a:r>
-              <a:t>3. So What? - why this matters to an investor</a:t>
+              <a:t/>
+            </a:r>
+          </a:p>
+          <a:p>
+            <a:r>
+              <a:t/>
+            </a:r>
+          </a:p>
+          <a:p>
+            <a:r>
+              <a:t/>
+            </a:r>
+          </a:p>
+          <a:p>
+            <a:r>
+              <a:t/>
             </a:r>
           </a:p>
           <a:p/>
           <a:p>
             <a:r>
-              <a:t>Challenge every claim and rate my evidence as Strong, Moderate, Weak, or Assumption. Be honest and push back where my evidence is thin.</a:t>
+              <a:t/>
             </a:r>
           </a:p>
         </p:txBody>
@@ -606,34 +611,39 @@
           <a:lstStyle/>
           <a:p>
             <a:r>
-              <a:t>AI PROMPT (paste into ChatGPT or Claude):</a:t>
+              <a:t>AI PROMPT (paste into ChatGPT or Claude):
+I am building [describe your startup in 2-3 sentences]. Help me build my pitch narrative. For each of these 10 elements (Hook, Problem, Solution, Market, Product, Business Model, Traction, Team, Vision, The Ask), ask me about:
+1. Key Narrative - the core message for this element
+2. Proof Points - what backs it up and makes it credible
+3. So What? - why an investor should care
+Challenge weak claims and rate my pitch readiness as Strong, Moderate, Weak, or Assumption. Help me build a compelling story, not just a list of facts.</a:t>
             </a:r>
           </a:p>
           <a:p/>
           <a:p>
             <a:r>
-              <a:t>I am building [describe your startup in 2-3 sentences]. Help me fill in my evidence grid. For each of these 10 elements (Hook, Problem, Solution, Market, Product, Business Model, Traction, Team, Vision, The Ask), ask me about:</a:t>
-            </a:r>
-          </a:p>
-          <a:p>
-            <a:r>
-              <a:t>1. Key Narrative - the core message for this element</a:t>
-            </a:r>
-          </a:p>
-          <a:p>
-            <a:r>
-              <a:t>2. Proof Points - specific evidence that backs it up</a:t>
-            </a:r>
-          </a:p>
-          <a:p>
-            <a:r>
-              <a:t>3. So What? - why this matters to an investor</a:t>
+              <a:t/>
+            </a:r>
+          </a:p>
+          <a:p>
+            <a:r>
+              <a:t/>
+            </a:r>
+          </a:p>
+          <a:p>
+            <a:r>
+              <a:t/>
+            </a:r>
+          </a:p>
+          <a:p>
+            <a:r>
+              <a:t/>
             </a:r>
           </a:p>
           <a:p/>
           <a:p>
             <a:r>
-              <a:t>Challenge every claim and rate my evidence as Strong, Moderate, Weak, or Assumption. Be honest and push back where my evidence is thin.</a:t>
+              <a:t/>
             </a:r>
           </a:p>
         </p:txBody>
@@ -703,34 +713,39 @@
           <a:lstStyle/>
           <a:p>
             <a:r>
-              <a:t>AI PROMPT (paste into ChatGPT or Claude):</a:t>
+              <a:t>AI PROMPT (paste into ChatGPT or Claude):
+I am building [describe your startup in 2-3 sentences]. Help me build my pitch narrative. For each of these 10 elements (Hook, Problem, Solution, Market, Product, Business Model, Traction, Team, Vision, The Ask), ask me about:
+1. Key Narrative - the core message for this element
+2. Proof Points - what backs it up and makes it credible
+3. So What? - why an investor should care
+Challenge weak claims and rate my pitch readiness as Strong, Moderate, Weak, or Assumption. Help me build a compelling story, not just a list of facts.</a:t>
             </a:r>
           </a:p>
           <a:p/>
           <a:p>
             <a:r>
-              <a:t>I am building [describe your startup in 2-3 sentences]. Help me fill in my evidence grid. For each of these 10 elements (Hook, Problem, Solution, Market, Product, Business Model, Traction, Team, Vision, The Ask), ask me about:</a:t>
-            </a:r>
-          </a:p>
-          <a:p>
-            <a:r>
-              <a:t>1. Key Narrative - the core message for this element</a:t>
-            </a:r>
-          </a:p>
-          <a:p>
-            <a:r>
-              <a:t>2. Proof Points - specific evidence that backs it up</a:t>
-            </a:r>
-          </a:p>
-          <a:p>
-            <a:r>
-              <a:t>3. So What? - why this matters to an investor</a:t>
+              <a:t/>
+            </a:r>
+          </a:p>
+          <a:p>
+            <a:r>
+              <a:t/>
+            </a:r>
+          </a:p>
+          <a:p>
+            <a:r>
+              <a:t/>
+            </a:r>
+          </a:p>
+          <a:p>
+            <a:r>
+              <a:t/>
             </a:r>
           </a:p>
           <a:p/>
           <a:p>
             <a:r>
-              <a:t>Challenge every claim and rate my evidence as Strong, Moderate, Weak, or Assumption. Be honest and push back where my evidence is thin.</a:t>
+              <a:t/>
             </a:r>
           </a:p>
         </p:txBody>
@@ -800,34 +815,39 @@
           <a:lstStyle/>
           <a:p>
             <a:r>
-              <a:t>AI PROMPT (paste into ChatGPT or Claude):</a:t>
+              <a:t>AI PROMPT (paste into ChatGPT or Claude):
+I am building [describe your startup in 2-3 sentences]. Help me build my pitch narrative. For each of these 10 elements (Hook, Problem, Solution, Market, Product, Business Model, Traction, Team, Vision, The Ask), ask me about:
+1. Key Narrative - the core message for this element
+2. Proof Points - what backs it up and makes it credible
+3. So What? - why an investor should care
+Challenge weak claims and rate my pitch readiness as Strong, Moderate, Weak, or Assumption. Help me build a compelling story, not just a list of facts.</a:t>
             </a:r>
           </a:p>
           <a:p/>
           <a:p>
             <a:r>
-              <a:t>I am building [describe your startup in 2-3 sentences]. Help me fill in my evidence grid. For each of these 10 elements (Hook, Problem, Solution, Market, Product, Business Model, Traction, Team, Vision, The Ask), ask me about:</a:t>
-            </a:r>
-          </a:p>
-          <a:p>
-            <a:r>
-              <a:t>1. Key Narrative - the core message for this element</a:t>
-            </a:r>
-          </a:p>
-          <a:p>
-            <a:r>
-              <a:t>2. Proof Points - specific evidence that backs it up</a:t>
-            </a:r>
-          </a:p>
-          <a:p>
-            <a:r>
-              <a:t>3. So What? - why this matters to an investor</a:t>
+              <a:t/>
+            </a:r>
+          </a:p>
+          <a:p>
+            <a:r>
+              <a:t/>
+            </a:r>
+          </a:p>
+          <a:p>
+            <a:r>
+              <a:t/>
+            </a:r>
+          </a:p>
+          <a:p>
+            <a:r>
+              <a:t/>
             </a:r>
           </a:p>
           <a:p/>
           <a:p>
             <a:r>
-              <a:t>Challenge every claim and rate my evidence as Strong, Moderate, Weak, or Assumption. Be honest and push back where my evidence is thin.</a:t>
+              <a:t/>
             </a:r>
           </a:p>
         </p:txBody>
@@ -897,34 +917,39 @@
           <a:lstStyle/>
           <a:p>
             <a:r>
-              <a:t>AI PROMPT (paste into ChatGPT or Claude):</a:t>
+              <a:t>AI PROMPT (paste into ChatGPT or Claude):
+I am building [describe your startup in 2-3 sentences]. Help me build my pitch narrative. For each of these 10 elements (Hook, Problem, Solution, Market, Product, Business Model, Traction, Team, Vision, The Ask), ask me about:
+1. Key Narrative - the core message for this element
+2. Proof Points - what backs it up and makes it credible
+3. So What? - why an investor should care
+Challenge weak claims and rate my pitch readiness as Strong, Moderate, Weak, or Assumption. Help me build a compelling story, not just a list of facts.</a:t>
             </a:r>
           </a:p>
           <a:p/>
           <a:p>
             <a:r>
-              <a:t>I am building [describe your startup in 2-3 sentences]. Help me fill in my evidence grid. For each of these 10 elements (Hook, Problem, Solution, Market, Product, Business Model, Traction, Team, Vision, The Ask), ask me about:</a:t>
-            </a:r>
-          </a:p>
-          <a:p>
-            <a:r>
-              <a:t>1. Key Narrative - the core message for this element</a:t>
-            </a:r>
-          </a:p>
-          <a:p>
-            <a:r>
-              <a:t>2. Proof Points - specific evidence that backs it up</a:t>
-            </a:r>
-          </a:p>
-          <a:p>
-            <a:r>
-              <a:t>3. So What? - why this matters to an investor</a:t>
+              <a:t/>
+            </a:r>
+          </a:p>
+          <a:p>
+            <a:r>
+              <a:t/>
+            </a:r>
+          </a:p>
+          <a:p>
+            <a:r>
+              <a:t/>
+            </a:r>
+          </a:p>
+          <a:p>
+            <a:r>
+              <a:t/>
             </a:r>
           </a:p>
           <a:p/>
           <a:p>
             <a:r>
-              <a:t>Challenge every claim and rate my evidence as Strong, Moderate, Weak, or Assumption. Be honest and push back where my evidence is thin.</a:t>
+              <a:t/>
             </a:r>
           </a:p>
         </p:txBody>
@@ -994,34 +1019,39 @@
           <a:lstStyle/>
           <a:p>
             <a:r>
-              <a:t>AI PROMPT (paste into ChatGPT or Claude):</a:t>
+              <a:t>AI PROMPT (paste into ChatGPT or Claude):
+I am building [describe your startup in 2-3 sentences]. Help me build my pitch narrative. For each of these 10 elements (Hook, Problem, Solution, Market, Product, Business Model, Traction, Team, Vision, The Ask), ask me about:
+1. Key Narrative - the core message for this element
+2. Proof Points - what backs it up and makes it credible
+3. So What? - why an investor should care
+Challenge weak claims and rate my pitch readiness as Strong, Moderate, Weak, or Assumption. Help me build a compelling story, not just a list of facts.</a:t>
             </a:r>
           </a:p>
           <a:p/>
           <a:p>
             <a:r>
-              <a:t>I am building [describe your startup in 2-3 sentences]. Help me fill in my evidence grid. For each of these 10 elements (Hook, Problem, Solution, Market, Product, Business Model, Traction, Team, Vision, The Ask), ask me about:</a:t>
-            </a:r>
-          </a:p>
-          <a:p>
-            <a:r>
-              <a:t>1. Key Narrative - the core message for this element</a:t>
-            </a:r>
-          </a:p>
-          <a:p>
-            <a:r>
-              <a:t>2. Proof Points - specific evidence that backs it up</a:t>
-            </a:r>
-          </a:p>
-          <a:p>
-            <a:r>
-              <a:t>3. So What? - why this matters to an investor</a:t>
+              <a:t/>
+            </a:r>
+          </a:p>
+          <a:p>
+            <a:r>
+              <a:t/>
+            </a:r>
+          </a:p>
+          <a:p>
+            <a:r>
+              <a:t/>
+            </a:r>
+          </a:p>
+          <a:p>
+            <a:r>
+              <a:t/>
             </a:r>
           </a:p>
           <a:p/>
           <a:p>
             <a:r>
-              <a:t>Challenge every claim and rate my evidence as Strong, Moderate, Weak, or Assumption. Be honest and push back where my evidence is thin.</a:t>
+              <a:t/>
             </a:r>
           </a:p>
         </p:txBody>
@@ -1091,34 +1121,39 @@
           <a:lstStyle/>
           <a:p>
             <a:r>
-              <a:t>AI PROMPT (paste into ChatGPT or Claude):</a:t>
+              <a:t>AI PROMPT (paste into ChatGPT or Claude):
+I am building [describe your startup in 2-3 sentences]. Help me build my pitch narrative. For each of these 10 elements (Hook, Problem, Solution, Market, Product, Business Model, Traction, Team, Vision, The Ask), ask me about:
+1. Key Narrative - the core message for this element
+2. Proof Points - what backs it up and makes it credible
+3. So What? - why an investor should care
+Challenge weak claims and rate my pitch readiness as Strong, Moderate, Weak, or Assumption. Help me build a compelling story, not just a list of facts.</a:t>
             </a:r>
           </a:p>
           <a:p/>
           <a:p>
             <a:r>
-              <a:t>I am building [describe your startup in 2-3 sentences]. Help me fill in my evidence grid. For each of these 10 elements (Hook, Problem, Solution, Market, Product, Business Model, Traction, Team, Vision, The Ask), ask me about:</a:t>
-            </a:r>
-          </a:p>
-          <a:p>
-            <a:r>
-              <a:t>1. Key Narrative - the core message for this element</a:t>
-            </a:r>
-          </a:p>
-          <a:p>
-            <a:r>
-              <a:t>2. Proof Points - specific evidence that backs it up</a:t>
-            </a:r>
-          </a:p>
-          <a:p>
-            <a:r>
-              <a:t>3. So What? - why this matters to an investor</a:t>
+              <a:t/>
+            </a:r>
+          </a:p>
+          <a:p>
+            <a:r>
+              <a:t/>
+            </a:r>
+          </a:p>
+          <a:p>
+            <a:r>
+              <a:t/>
+            </a:r>
+          </a:p>
+          <a:p>
+            <a:r>
+              <a:t/>
             </a:r>
           </a:p>
           <a:p/>
           <a:p>
             <a:r>
-              <a:t>Challenge every claim and rate my evidence as Strong, Moderate, Weak, or Assumption. Be honest and push back where my evidence is thin.</a:t>
+              <a:t/>
             </a:r>
           </a:p>
         </p:txBody>
@@ -4170,7 +4205,7 @@
                 </a:solidFill>
                 <a:latin typeface="Calibri"/>
               </a:rPr>
-              <a:t>Evidence Grid + Storytelling</a:t>
+              <a:t>Pitch Substance + Storytelling</a:t>
             </a:r>
           </a:p>
         </p:txBody>
@@ -4222,7 +4257,7 @@
                 </a:solidFill>
                 <a:latin typeface="Calibri"/>
               </a:rPr>
-              <a:t>The Evidence Grid</a:t>
+              <a:t>The Pitch Substance</a:t>
             </a:r>
           </a:p>
         </p:txBody>
@@ -4477,7 +4512,7 @@
                 </a:solidFill>
                 <a:latin typeface="Calibri"/>
               </a:rPr>
-              <a:t>Evidence Grid Template</a:t>
+              <a:t>Pitch Substance Template</a:t>
             </a:r>
           </a:p>
         </p:txBody>

</xml_diff>